<commit_message>
docs(stage20): validate four course presentation decks
</commit_message>
<xml_diff>
--- a/reports/stage20/presentations/01_KY_NANG_LAP_TRINH_NANG_CAO_WORKSPHERE.pptx
+++ b/reports/stage20/presentations/01_KY_NANG_LAP_TRINH_NANG_CAO_WORKSPHERE.pptx
@@ -536,7 +536,7 @@
           <a:p/>
           <a:p>
             <a:r>
-              <a:t>THỜI LƯỢNG DỰ KIẾN: 1 phút (PROJECT_PROPOSAL)</a:t>
+              <a:t>THỜI LƯỢNG DỰ KIẾN: 20 giây (~0.3 phút) (PROJECT_PROPOSAL)</a:t>
             </a:r>
           </a:p>
           <a:p>
@@ -648,7 +648,7 @@
           <a:p/>
           <a:p>
             <a:r>
-              <a:t>THỜI LƯỢNG DỰ KIẾN: 1.5 phút (PROJECT_PROPOSAL)</a:t>
+              <a:t>THỜI LƯỢNG DỰ KIẾN: 65 giây (~1.1 phút) (PROJECT_PROPOSAL)</a:t>
             </a:r>
           </a:p>
           <a:p>
@@ -760,7 +760,7 @@
           <a:p/>
           <a:p>
             <a:r>
-              <a:t>THỜI LƯỢNG DỰ KIẾN: 1.5 phút (PROJECT_PROPOSAL)</a:t>
+              <a:t>THỜI LƯỢNG DỰ KIẾN: 75 giây (~1.2 phút) (PROJECT_PROPOSAL)</a:t>
             </a:r>
           </a:p>
           <a:p>
@@ -872,7 +872,7 @@
           <a:p/>
           <a:p>
             <a:r>
-              <a:t>THỜI LƯỢNG DỰ KIẾN: 1.5 phút (PROJECT_PROPOSAL)</a:t>
+              <a:t>THỜI LƯỢNG DỰ KIẾN: 60 giây (~1.0 phút) (PROJECT_PROPOSAL)</a:t>
             </a:r>
           </a:p>
           <a:p>
@@ -984,7 +984,7 @@
           <a:p/>
           <a:p>
             <a:r>
-              <a:t>THỜI LƯỢNG DỰ KIẾN: 1.5 phút (PROJECT_PROPOSAL)</a:t>
+              <a:t>THỜI LƯỢNG DỰ KIẾN: 65 giây (~1.1 phút) (PROJECT_PROPOSAL)</a:t>
             </a:r>
           </a:p>
           <a:p>
@@ -1096,7 +1096,7 @@
           <a:p/>
           <a:p>
             <a:r>
-              <a:t>THỜI LƯỢNG DỰ KIẾN: 1.5 phút (PROJECT_PROPOSAL)</a:t>
+              <a:t>THỜI LƯỢNG DỰ KIẾN: 75 giây (~1.2 phút) (PROJECT_PROPOSAL)</a:t>
             </a:r>
           </a:p>
           <a:p>
@@ -1208,7 +1208,7 @@
           <a:p/>
           <a:p>
             <a:r>
-              <a:t>THỜI LƯỢNG DỰ KIẾN: 1.5 phút (PROJECT_PROPOSAL)</a:t>
+              <a:t>THỜI LƯỢNG DỰ KIẾN: 65 giây (~1.1 phút) (PROJECT_PROPOSAL)</a:t>
             </a:r>
           </a:p>
           <a:p>
@@ -1320,7 +1320,7 @@
           <a:p/>
           <a:p>
             <a:r>
-              <a:t>THỜI LƯỢNG DỰ KIẾN: 1.5 phút (PROJECT_PROPOSAL)</a:t>
+              <a:t>THỜI LƯỢNG DỰ KIẾN: 50 giây (~0.8 phút) (PROJECT_PROPOSAL)</a:t>
             </a:r>
           </a:p>
           <a:p>
@@ -1432,7 +1432,7 @@
           <a:p/>
           <a:p>
             <a:r>
-              <a:t>THỜI LƯỢNG DỰ KIẾN: 1.5 phút (PROJECT_PROPOSAL)</a:t>
+              <a:t>THỜI LƯỢNG DỰ KIẾN: 45 giây (~0.8 phút) (PROJECT_PROPOSAL)</a:t>
             </a:r>
           </a:p>
           <a:p>
@@ -1544,7 +1544,7 @@
           <a:p/>
           <a:p>
             <a:r>
-              <a:t>THỜI LƯỢNG DỰ KIẾN: 1 phút (PROJECT_PROPOSAL)</a:t>
+              <a:t>THỜI LƯỢNG DỰ KIẾN: 30 giây (~0.5 phút) (PROJECT_PROPOSAL)</a:t>
             </a:r>
           </a:p>
           <a:p>
@@ -1656,7 +1656,7 @@
           <a:p/>
           <a:p>
             <a:r>
-              <a:t>THỜI LƯỢNG DỰ KIẾN: 1.5 phút (PROJECT_PROPOSAL)</a:t>
+              <a:t>THỜI LƯỢNG DỰ KIẾN: 45 giây (~0.8 phút) (PROJECT_PROPOSAL)</a:t>
             </a:r>
           </a:p>
           <a:p>
@@ -1768,7 +1768,7 @@
           <a:p/>
           <a:p>
             <a:r>
-              <a:t>THỜI LƯỢNG DỰ KIẾN: 1.5 phút (PROJECT_PROPOSAL)</a:t>
+              <a:t>THỜI LƯỢNG DỰ KIẾN: 60 giây (~1.0 phút) (PROJECT_PROPOSAL)</a:t>
             </a:r>
           </a:p>
           <a:p>
@@ -1880,7 +1880,7 @@
           <a:p/>
           <a:p>
             <a:r>
-              <a:t>THỜI LƯỢNG DỰ KIẾN: 1.5 phút (PROJECT_PROPOSAL)</a:t>
+              <a:t>THỜI LƯỢNG DỰ KIẾN: 75 giây (~1.2 phút) (PROJECT_PROPOSAL)</a:t>
             </a:r>
           </a:p>
           <a:p>
@@ -1992,7 +1992,7 @@
           <a:p/>
           <a:p>
             <a:r>
-              <a:t>THỜI LƯỢNG DỰ KIẾN: 1.5 phút (PROJECT_PROPOSAL)</a:t>
+              <a:t>THỜI LƯỢNG DỰ KIẾN: 60 giây (~1.0 phút) (PROJECT_PROPOSAL)</a:t>
             </a:r>
           </a:p>
           <a:p>
@@ -2104,7 +2104,7 @@
           <a:p/>
           <a:p>
             <a:r>
-              <a:t>THỜI LƯỢNG DỰ KIẾN: 1.5 phút (PROJECT_PROPOSAL)</a:t>
+              <a:t>THỜI LƯỢNG DỰ KIẾN: 50 giây (~0.8 phút) (PROJECT_PROPOSAL)</a:t>
             </a:r>
           </a:p>
           <a:p>
@@ -2216,7 +2216,7 @@
           <a:p/>
           <a:p>
             <a:r>
-              <a:t>THỜI LƯỢNG DỰ KIẾN: 1.5 phút (PROJECT_PROPOSAL)</a:t>
+              <a:t>THỜI LƯỢNG DỰ KIẾN: 75 giây (~1.2 phút) (PROJECT_PROPOSAL)</a:t>
             </a:r>
           </a:p>
           <a:p>
@@ -2328,7 +2328,7 @@
           <a:p/>
           <a:p>
             <a:r>
-              <a:t>THỜI LƯỢNG DỰ KIẾN: 1.5 phút (PROJECT_PROPOSAL)</a:t>
+              <a:t>THỜI LƯỢNG DỰ KIẾN: 60 giây (~1.0 phút) (PROJECT_PROPOSAL)</a:t>
             </a:r>
           </a:p>
           <a:p>
@@ -2440,7 +2440,7 @@
           <a:p/>
           <a:p>
             <a:r>
-              <a:t>THỜI LƯỢNG DỰ KIẾN: 1.5 phút (PROJECT_PROPOSAL)</a:t>
+              <a:t>THỜI LƯỢNG DỰ KIẾN: 70 giây (~1.2 phút) (PROJECT_PROPOSAL)</a:t>
             </a:r>
           </a:p>
           <a:p>

</xml_diff>

<commit_message>
docs(stage20): correct presentation facts and review status
</commit_message>
<xml_diff>
--- a/reports/stage20/presentations/01_KY_NANG_LAP_TRINH_NANG_CAO_WORKSPHERE.pptx
+++ b/reports/stage20/presentations/01_KY_NANG_LAP_TRINH_NANG_CAO_WORKSPHERE.pptx
@@ -743,7 +743,7 @@
           <a:lstStyle/>
           <a:p>
             <a:r>
-              <a:t>MỤC TIÊU SLIDE: Trình bày kiến trúc bảo mật phân tầng hiện đại dựa trên Spring Security 6.</a:t>
+              <a:t>MỤC TIÊU SLIDE: Trình bày kiến trúc bảo mật phân tầng hiện đại dựa trên Spring Security.</a:t>
             </a:r>
           </a:p>
           <a:p/>
@@ -9768,7 +9768,7 @@
               </a:defRPr>
             </a:pPr>
             <a:r>
-              <a:t>• Spring Security 6: Cơ chế lọc stateless, phân quyền RBAC dựa trên Method Security.</a:t>
+              <a:t>• Spring Security: Cơ chế lọc stateless, phân quyền RBAC dựa trên Method Security.</a:t>
             </a:r>
           </a:p>
           <a:p>

</xml_diff>

<commit_message>
docs(stage20): close manual presentation review
</commit_message>
<xml_diff>
--- a/reports/stage20/presentations/01_KY_NANG_LAP_TRINH_NANG_CAO_WORKSPHERE.pptx
+++ b/reports/stage20/presentations/01_KY_NANG_LAP_TRINH_NANG_CAO_WORKSPHERE.pptx
@@ -648,7 +648,7 @@
           <a:p/>
           <a:p>
             <a:r>
-              <a:t>THỜI LƯỢNG DỰ KIẾN: 65 giây (~1.1 phút) (PROJECT_PROPOSAL)</a:t>
+              <a:t>THỜI LƯỢNG DỰ KIẾN: 50 giây (~0.8 phút) (PROJECT_PROPOSAL)</a:t>
             </a:r>
           </a:p>
           <a:p>
@@ -760,7 +760,7 @@
           <a:p/>
           <a:p>
             <a:r>
-              <a:t>THỜI LƯỢNG DỰ KIẾN: 75 giây (~1.2 phút) (PROJECT_PROPOSAL)</a:t>
+              <a:t>THỜI LƯỢNG DỰ KIẾN: 60 giây (~1.0 phút) (PROJECT_PROPOSAL)</a:t>
             </a:r>
           </a:p>
           <a:p>
@@ -872,7 +872,7 @@
           <a:p/>
           <a:p>
             <a:r>
-              <a:t>THỜI LƯỢNG DỰ KIẾN: 60 giây (~1.0 phút) (PROJECT_PROPOSAL)</a:t>
+              <a:t>THỜI LƯỢNG DỰ KIẾN: 45 giây (~0.8 phút) (PROJECT_PROPOSAL)</a:t>
             </a:r>
           </a:p>
           <a:p>
@@ -984,7 +984,7 @@
           <a:p/>
           <a:p>
             <a:r>
-              <a:t>THỜI LƯỢNG DỰ KIẾN: 65 giây (~1.1 phút) (PROJECT_PROPOSAL)</a:t>
+              <a:t>THỜI LƯỢNG DỰ KIẾN: 50 giây (~0.8 phút) (PROJECT_PROPOSAL)</a:t>
             </a:r>
           </a:p>
           <a:p>
@@ -1096,7 +1096,7 @@
           <a:p/>
           <a:p>
             <a:r>
-              <a:t>THỜI LƯỢNG DỰ KIẾN: 75 giây (~1.2 phút) (PROJECT_PROPOSAL)</a:t>
+              <a:t>THỜI LƯỢNG DỰ KIẾN: 60 giây (~1.0 phút) (PROJECT_PROPOSAL)</a:t>
             </a:r>
           </a:p>
           <a:p>
@@ -1208,7 +1208,7 @@
           <a:p/>
           <a:p>
             <a:r>
-              <a:t>THỜI LƯỢNG DỰ KIẾN: 65 giây (~1.1 phút) (PROJECT_PROPOSAL)</a:t>
+              <a:t>THỜI LƯỢNG DỰ KIẾN: 50 giây (~0.8 phút) (PROJECT_PROPOSAL)</a:t>
             </a:r>
           </a:p>
           <a:p>
@@ -1320,7 +1320,7 @@
           <a:p/>
           <a:p>
             <a:r>
-              <a:t>THỜI LƯỢNG DỰ KIẾN: 50 giây (~0.8 phút) (PROJECT_PROPOSAL)</a:t>
+              <a:t>THỜI LƯỢNG DỰ KIẾN: 40 giây (~0.7 phút) (PROJECT_PROPOSAL)</a:t>
             </a:r>
           </a:p>
           <a:p>
@@ -1432,7 +1432,7 @@
           <a:p/>
           <a:p>
             <a:r>
-              <a:t>THỜI LƯỢNG DỰ KIẾN: 45 giây (~0.8 phút) (PROJECT_PROPOSAL)</a:t>
+              <a:t>THỜI LƯỢNG DỰ KIẾN: 35 giây (~0.6 phút) (PROJECT_PROPOSAL)</a:t>
             </a:r>
           </a:p>
           <a:p>
@@ -1544,7 +1544,7 @@
           <a:p/>
           <a:p>
             <a:r>
-              <a:t>THỜI LƯỢNG DỰ KIẾN: 30 giây (~0.5 phút) (PROJECT_PROPOSAL)</a:t>
+              <a:t>THỜI LƯỢNG DỰ KIẾN: 25 giây (~0.4 phút) (PROJECT_PROPOSAL)</a:t>
             </a:r>
           </a:p>
           <a:p>
@@ -1656,7 +1656,7 @@
           <a:p/>
           <a:p>
             <a:r>
-              <a:t>THỜI LƯỢNG DỰ KIẾN: 45 giây (~0.8 phút) (PROJECT_PROPOSAL)</a:t>
+              <a:t>THỜI LƯỢNG DỰ KIẾN: 35 giây (~0.6 phút) (PROJECT_PROPOSAL)</a:t>
             </a:r>
           </a:p>
           <a:p>
@@ -1768,7 +1768,7 @@
           <a:p/>
           <a:p>
             <a:r>
-              <a:t>THỜI LƯỢNG DỰ KIẾN: 60 giây (~1.0 phút) (PROJECT_PROPOSAL)</a:t>
+              <a:t>THỜI LƯỢNG DỰ KIẾN: 45 giây (~0.8 phút) (PROJECT_PROPOSAL)</a:t>
             </a:r>
           </a:p>
           <a:p>
@@ -1880,7 +1880,7 @@
           <a:p/>
           <a:p>
             <a:r>
-              <a:t>THỜI LƯỢNG DỰ KIẾN: 75 giây (~1.2 phút) (PROJECT_PROPOSAL)</a:t>
+              <a:t>THỜI LƯỢNG DỰ KIẾN: 60 giây (~1.0 phút) (PROJECT_PROPOSAL)</a:t>
             </a:r>
           </a:p>
           <a:p>
@@ -1992,7 +1992,7 @@
           <a:p/>
           <a:p>
             <a:r>
-              <a:t>THỜI LƯỢNG DỰ KIẾN: 60 giây (~1.0 phút) (PROJECT_PROPOSAL)</a:t>
+              <a:t>THỜI LƯỢNG DỰ KIẾN: 45 giây (~0.8 phút) (PROJECT_PROPOSAL)</a:t>
             </a:r>
           </a:p>
           <a:p>
@@ -2104,7 +2104,7 @@
           <a:p/>
           <a:p>
             <a:r>
-              <a:t>THỜI LƯỢNG DỰ KIẾN: 50 giây (~0.8 phút) (PROJECT_PROPOSAL)</a:t>
+              <a:t>THỜI LƯỢNG DỰ KIẾN: 40 giây (~0.7 phút) (PROJECT_PROPOSAL)</a:t>
             </a:r>
           </a:p>
           <a:p>
@@ -2216,7 +2216,7 @@
           <a:p/>
           <a:p>
             <a:r>
-              <a:t>THỜI LƯỢNG DỰ KIẾN: 75 giây (~1.2 phút) (PROJECT_PROPOSAL)</a:t>
+              <a:t>THỜI LƯỢNG DỰ KIẾN: 60 giây (~1.0 phút) (PROJECT_PROPOSAL)</a:t>
             </a:r>
           </a:p>
           <a:p>
@@ -2328,7 +2328,7 @@
           <a:p/>
           <a:p>
             <a:r>
-              <a:t>THỜI LƯỢNG DỰ KIẾN: 60 giây (~1.0 phút) (PROJECT_PROPOSAL)</a:t>
+              <a:t>THỜI LƯỢNG DỰ KIẾN: 45 giây (~0.8 phút) (PROJECT_PROPOSAL)</a:t>
             </a:r>
           </a:p>
           <a:p>
@@ -2440,7 +2440,7 @@
           <a:p/>
           <a:p>
             <a:r>
-              <a:t>THỜI LƯỢNG DỰ KIẾN: 70 giây (~1.2 phút) (PROJECT_PROPOSAL)</a:t>
+              <a:t>THỜI LƯỢNG DỰ KIẾN: 55 giây (~0.9 phút) (PROJECT_PROPOSAL)</a:t>
             </a:r>
           </a:p>
           <a:p>

</xml_diff>